<commit_message>
sop(general/metriq-pitch-deck): drop Option labels; video shows the parts photo only
Slides 4 and 5 lose their "Option A/B" labels and both stay in the deck.
The demo video skips slide 5 (generated cartons), so it runs 1 min 48 s.
The open TODO is now the slide 9 price only.

Co-Authored-By: Claude Opus 5.5 <noreply@anthropic.com>
Claude-Session: https://claude.ai/code/session_01KBsTQwRoyD7wtmr1PrKPfN
</commit_message>
<xml_diff>
--- a/content/general/attachments/metriq-pitch-deck.pptx
+++ b/content/general/attachments/metriq-pitch-deck.pptx
@@ -120,13 +120,13 @@
   <p:extLst>
     <p:ext uri="{521415D9-36F7-43E2-AB2F-B90AF26B5E84}">
       <p14:sectionLst xmlns:p14="http://schemas.microsoft.com/office/powerpoint/2010/main">
-        <p14:section name="Intro" id="{5f47fff0-a35d-6f50-734a-f3ca927071c9}">
+        <p14:section name="Intro" id="{88364f4d-827c-fc8f-a4b7-3d89588adcd5}">
           <p14:sldIdLst>
             <p14:sldId id="256"/>
             <p14:sldId id="257"/>
           </p14:sldIdLst>
         </p14:section>
-        <p14:section name="Capability" id="{0fb0a2c0-0ae3-cbe0-d000-d67adb82ecdf}">
+        <p14:section name="Capability" id="{64aef7c9-6270-6663-169c-63e0c7a7a3c9}">
           <p14:sldIdLst>
             <p14:sldId id="258"/>
             <p14:sldId id="259"/>
@@ -136,7 +136,7 @@
             <p14:sldId id="263"/>
           </p14:sldIdLst>
         </p14:section>
-        <p14:section name="Why MetriQ" id="{42f4896f-b927-d816-4531-5ed524835ca6}">
+        <p14:section name="Why MetriQ" id="{ec0e4557-dab9-8235-72a3-96ab67d5cb30}">
           <p14:sldIdLst>
             <p14:sldId id="264"/>
             <p14:sldId id="265"/>
@@ -144,12 +144,12 @@
             <p14:sldId id="267"/>
           </p14:sldIdLst>
         </p14:section>
-        <p14:section name="Your line" id="{cfb189e3-44fe-c680-d96a-f74335ab5b5f}">
+        <p14:section name="Your line" id="{dd72a709-73de-956f-9250-b25031025209}">
           <p14:sldIdLst>
             <p14:sldId id="268"/>
           </p14:sldIdLst>
         </p14:section>
-        <p14:section name="Next" id="{a342f1c0-98e5-2fe2-28ee-d848613cdf6f}">
+        <p14:section name="Next" id="{5b775e30-9d7d-d1eb-efd8-8b74683e5070}">
           <p14:sldIdLst>
             <p14:sldId id="269"/>
           </p14:sldIdLst>
@@ -1587,7 +1587,7 @@
           <a:p>
             <a:r>
               <a:rPr lang="en-US" dirty="0"/>
-              <a:t>Option A. One camera frame of mixed fasteners: MetriQ counts and identifies every part, measures each screw, checks the finish colour, finds the two broken bolts and the one lying the wrong way up, flags the capacitor it was never taught, and gives the verdict. Readings drawn on a real photo for illustration.</a:t>
+              <a:t>One camera frame of mixed fasteners: MetriQ counts and identifies every part, measures each screw, checks the finish colour, finds the two broken bolts and the one lying the wrong way up, flags the capacitor it was never taught, and gives the verdict. Readings drawn on a real photo for illustration.</a:t>
             </a:r>
             <a:endParaRPr lang="en-US" dirty="0"/>
           </a:p>
@@ -1675,7 +1675,7 @@
           <a:p>
             <a:r>
               <a:rPr lang="en-US" dirty="0"/>
-              <a:t>Option B. From above, MetriQ counts the cartons, checks length and width and the label colour. Then the view turns 3D: it checks height, finds the crushed corner by its height, and gives the verdict.</a:t>
+              <a:t>From above, MetriQ counts the cartons, checks length and width and the label colour. Then the view turns 3D: it checks height, finds the crushed corner by its height, and gives the verdict.</a:t>
             </a:r>
             <a:endParaRPr lang="en-US" dirty="0"/>
           </a:p>
@@ -12834,7 +12834,7 @@
                   <a:schemeClr val="accent6"/>
                 </a:solidFill>
               </a:rPr>
-              <a:t>Option A · real frame, MetriQ readings drawn for illustration.</a:t>
+              <a:t>Real frame, MetriQ readings drawn for illustration.</a:t>
             </a:r>
             <a:endParaRPr lang="en-US" sz="900" dirty="0"/>
           </a:p>
@@ -19478,7 +19478,7 @@
                   <a:schemeClr val="accent6"/>
                 </a:solidFill>
               </a:rPr>
-              <a:t>Option B · generated product, MetriQ readings drawn for illustration.</a:t>
+              <a:t>Generated product, MetriQ readings drawn for illustration.</a:t>
             </a:r>
             <a:endParaRPr lang="en-US" sz="900" dirty="0"/>
           </a:p>

</xml_diff>